<commit_message>
Presentation: eye validation with bends from the re-analysed INTERCONNECT traces
Slide 19 now compares the INTERCONNECT eyes (saved traces re-folded from
where the modulation arrives) with the Python eyes for 0-4 bends: eye
height within 0.4 %, OMA within 0.2 %. Docs: the eye bend check and its
result.

Co-Authored-By: Claude Opus 5.5 <noreply@anthropic.com>
Claude-Session: https://claude.ai/code/session_01PF7RKNjFsSkyjm1syGCUrV
</commit_message>
<xml_diff>
--- a/docs/Bends_in_INTERCONNECT.pptx
+++ b/docs/Bends_in_INTERCONNECT.pptx
@@ -1233,7 +1233,7 @@
           <a:lstStyle/>
           <a:p>
             <a:r>
-              <a:t>Eye validation for zero to four bends. Navy: the Python eye of each device. The bends close the eye slightly (height and ER drop with N), consistent with the lower EO bandwidth. The INTERCONNECT eyes are recorded by an oscilloscope on the photodiode and folded by exactly the same code as the Python eye, so the numbers compare directly. The first INTERCONNECT run cannot be used: the folding started 8 UI into the run, inside the 32-UI start-up interval in which the electrode Compound's filter has not yet delivered any modulation; those flat traces sit between the levels and zero the eye height. The folding now starts where the modulation arrives; the saved traces will be re-analysed.</a:t>
+              <a:t>Validation of the final eye schematic against the Python eye, for 0 to 4 bends (same devices as the EO validation). An oscilloscope records the INTERCONNECT photocurrent; it is folded into a two-symbol eye and measured by exactly the same code as the Python eye (eye height = lowest '1' minus highest '0' at the best instant; OMA = mean '1' minus mean '0'). Top: navy = Python, orange = INTERCONNECT, on top of each other for every N. Eye height agrees within 0.4 % and OMA within 0.2 %; both tools show the same slow closure of the eye as bends are added. The extinction ratio is the ratio of the '1' level to a '0' level of only about 0.1 mA (the modulator is driven close to full extinction), so a 0.01 mA difference in the mean '0' level moves it by up to 0.7 dB; the two tools also use different bit patterns, which changes the mean '0' level slightly when there is inter-symbol interference. INTERCONNECT's own start-up interval (32 symbols, appendix A4) is excluded from the folding.</a:t>
             </a:r>
           </a:p>
         </p:txBody>
@@ -17928,7 +17928,7 @@
                 </a:solidFill>
                 <a:latin typeface="Arial"/>
               </a:rPr>
-              <a:t>Eye with bends: INTERCONNECT vs Python</a:t>
+              <a:t>Eye with bends: validation</a:t>
             </a:r>
           </a:p>
         </p:txBody>
@@ -17967,7 +17967,7 @@
                 </a:solidFill>
                 <a:latin typeface="Arial"/>
               </a:rPr>
-              <a:t>100 Gb/s NRZ, 2 Vpp, noise off, no receiver filter</a:t>
+              <a:t>INTERCONNECT (TL electrode) vs Python, 100 Gb/s NRZ, 2 Vpp, noise off, no receiver filter</a:t>
             </a:r>
           </a:p>
         </p:txBody>
@@ -17988,8 +17988,32 @@
         </p:blipFill>
         <p:spPr>
           <a:xfrm>
-            <a:off x="822960" y="1463040"/>
-            <a:ext cx="10515600" cy="2867891"/>
+            <a:off x="1051560" y="1371600"/>
+            <a:ext cx="9966960" cy="2981767"/>
+          </a:xfrm>
+          <a:prstGeom prst="rect">
+            <a:avLst/>
+          </a:prstGeom>
+        </p:spPr>
+      </p:pic>
+      <p:pic>
+        <p:nvPicPr>
+          <p:cNvPr id="6" name="Picture 5" descr="final_eye_metrics.png"/>
+          <p:cNvPicPr>
+            <a:picLocks noChangeAspect="1"/>
+          </p:cNvPicPr>
+          <p:nvPr/>
+        </p:nvPicPr>
+        <p:blipFill>
+          <a:blip r:embed="rId3"/>
+          <a:stretch>
+            <a:fillRect/>
+          </a:stretch>
+        </p:blipFill>
+        <p:spPr>
+          <a:xfrm>
+            <a:off x="502920" y="4572000"/>
+            <a:ext cx="5081534" cy="2148840"/>
           </a:xfrm>
           <a:prstGeom prst="rect">
             <a:avLst/>
@@ -17998,28 +18022,28 @@
       </p:pic>
       <p:graphicFrame>
         <p:nvGraphicFramePr>
-          <p:cNvPr id="6" name="Table 5"/>
+          <p:cNvPr id="7" name="Table 6"/>
           <p:cNvGraphicFramePr>
             <a:graphicFrameLocks noGrp="1"/>
           </p:cNvGraphicFramePr>
           <p:nvPr/>
         </p:nvGraphicFramePr>
         <p:xfrm>
-          <a:off x="731520" y="4251960"/>
-          <a:ext cx="7315196" cy="2194560"/>
+          <a:off x="6812280" y="4617720"/>
+          <a:ext cx="2743197" cy="1810512"/>
         </p:xfrm>
         <a:graphic>
           <a:graphicData uri="http://schemas.openxmlformats.org/drawingml/2006/table">
             <a:tbl>
               <a:tblPr firstRow="0" bandRow="0"/>
               <a:tblGrid>
-                <a:gridCol w="599606"/>
-                <a:gridCol w="1918740"/>
-                <a:gridCol w="1439055"/>
-                <a:gridCol w="1918740"/>
-                <a:gridCol w="1439055"/>
+                <a:gridCol w="256031"/>
+                <a:gridCol w="694943"/>
+                <a:gridCol w="694943"/>
+                <a:gridCol w="548640"/>
+                <a:gridCol w="548640"/>
               </a:tblGrid>
-              <a:tr h="365760">
+              <a:tr h="301752">
                 <a:tc>
                   <a:txBody>
                     <a:bodyPr wrap="square"/>
@@ -18027,7 +18051,7 @@
                     <a:p>
                       <a:pPr algn="l"/>
                       <a:r>
-                        <a:rPr sz="1150" b="1" i="0">
+                        <a:rPr sz="1000" b="1" i="0">
                           <a:solidFill>
                             <a:srgbClr val="FFFFFF"/>
                           </a:solidFill>
@@ -18050,13 +18074,13 @@
                     <a:p>
                       <a:pPr algn="ctr"/>
                       <a:r>
-                        <a:rPr sz="1150" b="1" i="0">
+                        <a:rPr sz="1000" b="1" i="0">
                           <a:solidFill>
                             <a:srgbClr val="FFFFFF"/>
                           </a:solidFill>
                           <a:latin typeface="Arial"/>
                         </a:rPr>
-                        <a:t>eye height Python</a:t>
+                        <a:t>height Py</a:t>
                       </a:r>
                     </a:p>
                   </a:txBody>
@@ -18073,13 +18097,13 @@
                     <a:p>
                       <a:pPr algn="ctr"/>
                       <a:r>
-                        <a:rPr sz="1150" b="1" i="0">
+                        <a:rPr sz="1000" b="1" i="0">
                           <a:solidFill>
                             <a:srgbClr val="FFFFFF"/>
                           </a:solidFill>
                           <a:latin typeface="Arial"/>
                         </a:rPr>
-                        <a:t>ER Python</a:t>
+                        <a:t>height IC</a:t>
                       </a:r>
                     </a:p>
                   </a:txBody>
@@ -18096,13 +18120,13 @@
                     <a:p>
                       <a:pPr algn="ctr"/>
                       <a:r>
-                        <a:rPr sz="1150" b="1" i="0">
+                        <a:rPr sz="1000" b="1" i="0">
                           <a:solidFill>
                             <a:srgbClr val="FFFFFF"/>
                           </a:solidFill>
                           <a:latin typeface="Arial"/>
                         </a:rPr>
-                        <a:t>height IC / Python</a:t>
+                        <a:t>ER Py</a:t>
                       </a:r>
                     </a:p>
                   </a:txBody>
@@ -18119,7 +18143,7 @@
                     <a:p>
                       <a:pPr algn="ctr"/>
                       <a:r>
-                        <a:rPr sz="1150" b="1" i="0">
+                        <a:rPr sz="1000" b="1" i="0">
                           <a:solidFill>
                             <a:srgbClr val="FFFFFF"/>
                           </a:solidFill>
@@ -18136,7 +18160,7 @@
                   </a:tcPr>
                 </a:tc>
               </a:tr>
-              <a:tr h="365760">
+              <a:tr h="301752">
                 <a:tc>
                   <a:txBody>
                     <a:bodyPr wrap="square"/>
@@ -18144,7 +18168,7 @@
                     <a:p>
                       <a:pPr algn="l"/>
                       <a:r>
-                        <a:rPr sz="1150" b="1" i="0">
+                        <a:rPr sz="1000" b="1" i="0">
                           <a:solidFill>
                             <a:srgbClr val="1A1A1A"/>
                           </a:solidFill>
@@ -18167,13 +18191,13 @@
                     <a:p>
                       <a:pPr algn="ctr"/>
                       <a:r>
-                        <a:rPr sz="1150" b="0" i="0">
+                        <a:rPr sz="1000" b="0" i="0">
                           <a:solidFill>
                             <a:srgbClr val="1A1A1A"/>
                           </a:solidFill>
                           <a:latin typeface="Arial"/>
                         </a:rPr>
-                        <a:t>17.96 mA</a:t>
+                        <a:t>19.46</a:t>
                       </a:r>
                     </a:p>
                   </a:txBody>
@@ -18190,13 +18214,13 @@
                     <a:p>
                       <a:pPr algn="ctr"/>
                       <a:r>
-                        <a:rPr sz="1150" b="0" i="0">
+                        <a:rPr sz="1000" b="0" i="0">
                           <a:solidFill>
                             <a:srgbClr val="1A1A1A"/>
                           </a:solidFill>
                           <a:latin typeface="Arial"/>
                         </a:rPr>
-                        <a:t>18.3 dB</a:t>
+                        <a:t>19.46</a:t>
                       </a:r>
                     </a:p>
                   </a:txBody>
@@ -18213,13 +18237,13 @@
                     <a:p>
                       <a:pPr algn="ctr"/>
                       <a:r>
-                        <a:rPr sz="1150" b="0" i="0">
+                        <a:rPr sz="1000" b="0" i="0">
                           <a:solidFill>
                             <a:srgbClr val="1A1A1A"/>
                           </a:solidFill>
                           <a:latin typeface="Arial"/>
                         </a:rPr>
-                        <a:t>re-analysis</a:t>
+                        <a:t>25.2</a:t>
                       </a:r>
                     </a:p>
                   </a:txBody>
@@ -18236,13 +18260,13 @@
                     <a:p>
                       <a:pPr algn="ctr"/>
                       <a:r>
-                        <a:rPr sz="1150" b="0" i="0">
+                        <a:rPr sz="1000" b="0" i="0">
                           <a:solidFill>
                             <a:srgbClr val="1A1A1A"/>
                           </a:solidFill>
                           <a:latin typeface="Arial"/>
                         </a:rPr>
-                        <a:t>re-analysis</a:t>
+                        <a:t>25.3</a:t>
                       </a:r>
                     </a:p>
                   </a:txBody>
@@ -18253,7 +18277,7 @@
                   </a:tcPr>
                 </a:tc>
               </a:tr>
-              <a:tr h="365760">
+              <a:tr h="301752">
                 <a:tc>
                   <a:txBody>
                     <a:bodyPr wrap="square"/>
@@ -18261,7 +18285,7 @@
                     <a:p>
                       <a:pPr algn="l"/>
                       <a:r>
-                        <a:rPr sz="1150" b="1" i="0">
+                        <a:rPr sz="1000" b="1" i="0">
                           <a:solidFill>
                             <a:srgbClr val="1A1A1A"/>
                           </a:solidFill>
@@ -18284,13 +18308,13 @@
                     <a:p>
                       <a:pPr algn="ctr"/>
                       <a:r>
-                        <a:rPr sz="1150" b="0" i="0">
+                        <a:rPr sz="1000" b="0" i="0">
                           <a:solidFill>
                             <a:srgbClr val="1A1A1A"/>
                           </a:solidFill>
                           <a:latin typeface="Arial"/>
                         </a:rPr>
-                        <a:t>17.71 mA</a:t>
+                        <a:t>19.35</a:t>
                       </a:r>
                     </a:p>
                   </a:txBody>
@@ -18307,13 +18331,13 @@
                     <a:p>
                       <a:pPr algn="ctr"/>
                       <a:r>
-                        <a:rPr sz="1150" b="0" i="0">
+                        <a:rPr sz="1000" b="0" i="0">
                           <a:solidFill>
                             <a:srgbClr val="1A1A1A"/>
                           </a:solidFill>
                           <a:latin typeface="Arial"/>
                         </a:rPr>
-                        <a:t>17.9 dB</a:t>
+                        <a:t>19.32</a:t>
                       </a:r>
                     </a:p>
                   </a:txBody>
@@ -18330,13 +18354,13 @@
                     <a:p>
                       <a:pPr algn="ctr"/>
                       <a:r>
-                        <a:rPr sz="1150" b="0" i="0">
+                        <a:rPr sz="1000" b="0" i="0">
                           <a:solidFill>
                             <a:srgbClr val="1A1A1A"/>
                           </a:solidFill>
                           <a:latin typeface="Arial"/>
                         </a:rPr>
-                        <a:t>re-analysis</a:t>
+                        <a:t>24.0</a:t>
                       </a:r>
                     </a:p>
                   </a:txBody>
@@ -18353,13 +18377,13 @@
                     <a:p>
                       <a:pPr algn="ctr"/>
                       <a:r>
-                        <a:rPr sz="1150" b="0" i="0">
+                        <a:rPr sz="1000" b="0" i="0">
                           <a:solidFill>
                             <a:srgbClr val="1A1A1A"/>
                           </a:solidFill>
                           <a:latin typeface="Arial"/>
                         </a:rPr>
-                        <a:t>re-analysis</a:t>
+                        <a:t>24.5</a:t>
                       </a:r>
                     </a:p>
                   </a:txBody>
@@ -18370,7 +18394,7 @@
                   </a:tcPr>
                 </a:tc>
               </a:tr>
-              <a:tr h="365760">
+              <a:tr h="301752">
                 <a:tc>
                   <a:txBody>
                     <a:bodyPr wrap="square"/>
@@ -18378,7 +18402,7 @@
                     <a:p>
                       <a:pPr algn="l"/>
                       <a:r>
-                        <a:rPr sz="1150" b="1" i="0">
+                        <a:rPr sz="1000" b="1" i="0">
                           <a:solidFill>
                             <a:srgbClr val="1A1A1A"/>
                           </a:solidFill>
@@ -18401,13 +18425,13 @@
                     <a:p>
                       <a:pPr algn="ctr"/>
                       <a:r>
-                        <a:rPr sz="1150" b="0" i="0">
+                        <a:rPr sz="1000" b="0" i="0">
                           <a:solidFill>
                             <a:srgbClr val="1A1A1A"/>
                           </a:solidFill>
                           <a:latin typeface="Arial"/>
                         </a:rPr>
-                        <a:t>17.51 mA</a:t>
+                        <a:t>19.20</a:t>
                       </a:r>
                     </a:p>
                   </a:txBody>
@@ -18424,13 +18448,13 @@
                     <a:p>
                       <a:pPr algn="ctr"/>
                       <a:r>
-                        <a:rPr sz="1150" b="0" i="0">
+                        <a:rPr sz="1000" b="0" i="0">
                           <a:solidFill>
                             <a:srgbClr val="1A1A1A"/>
                           </a:solidFill>
                           <a:latin typeface="Arial"/>
                         </a:rPr>
-                        <a:t>17.5 dB</a:t>
+                        <a:t>19.19</a:t>
                       </a:r>
                     </a:p>
                   </a:txBody>
@@ -18447,13 +18471,13 @@
                     <a:p>
                       <a:pPr algn="ctr"/>
                       <a:r>
-                        <a:rPr sz="1150" b="0" i="0">
+                        <a:rPr sz="1000" b="0" i="0">
                           <a:solidFill>
                             <a:srgbClr val="1A1A1A"/>
                           </a:solidFill>
                           <a:latin typeface="Arial"/>
                         </a:rPr>
-                        <a:t>re-analysis</a:t>
+                        <a:t>22.9</a:t>
                       </a:r>
                     </a:p>
                   </a:txBody>
@@ -18470,13 +18494,13 @@
                     <a:p>
                       <a:pPr algn="ctr"/>
                       <a:r>
-                        <a:rPr sz="1150" b="0" i="0">
+                        <a:rPr sz="1000" b="0" i="0">
                           <a:solidFill>
                             <a:srgbClr val="1A1A1A"/>
                           </a:solidFill>
                           <a:latin typeface="Arial"/>
                         </a:rPr>
-                        <a:t>re-analysis</a:t>
+                        <a:t>23.6</a:t>
                       </a:r>
                     </a:p>
                   </a:txBody>
@@ -18487,7 +18511,7 @@
                   </a:tcPr>
                 </a:tc>
               </a:tr>
-              <a:tr h="365760">
+              <a:tr h="301752">
                 <a:tc>
                   <a:txBody>
                     <a:bodyPr wrap="square"/>
@@ -18495,7 +18519,7 @@
                     <a:p>
                       <a:pPr algn="l"/>
                       <a:r>
-                        <a:rPr sz="1150" b="1" i="0">
+                        <a:rPr sz="1000" b="1" i="0">
                           <a:solidFill>
                             <a:srgbClr val="1A1A1A"/>
                           </a:solidFill>
@@ -18518,13 +18542,13 @@
                     <a:p>
                       <a:pPr algn="ctr"/>
                       <a:r>
-                        <a:rPr sz="1150" b="0" i="0">
+                        <a:rPr sz="1000" b="0" i="0">
                           <a:solidFill>
                             <a:srgbClr val="1A1A1A"/>
                           </a:solidFill>
                           <a:latin typeface="Arial"/>
                         </a:rPr>
-                        <a:t>17.22 mA</a:t>
+                        <a:t>18.94</a:t>
                       </a:r>
                     </a:p>
                   </a:txBody>
@@ -18541,13 +18565,13 @@
                     <a:p>
                       <a:pPr algn="ctr"/>
                       <a:r>
-                        <a:rPr sz="1150" b="0" i="0">
+                        <a:rPr sz="1000" b="0" i="0">
                           <a:solidFill>
                             <a:srgbClr val="1A1A1A"/>
                           </a:solidFill>
                           <a:latin typeface="Arial"/>
                         </a:rPr>
-                        <a:t>17.0 dB</a:t>
+                        <a:t>19.01</a:t>
                       </a:r>
                     </a:p>
                   </a:txBody>
@@ -18564,13 +18588,13 @@
                     <a:p>
                       <a:pPr algn="ctr"/>
                       <a:r>
-                        <a:rPr sz="1150" b="0" i="0">
+                        <a:rPr sz="1000" b="0" i="0">
                           <a:solidFill>
                             <a:srgbClr val="1A1A1A"/>
                           </a:solidFill>
                           <a:latin typeface="Arial"/>
                         </a:rPr>
-                        <a:t>re-analysis</a:t>
+                        <a:t>22.1</a:t>
                       </a:r>
                     </a:p>
                   </a:txBody>
@@ -18587,13 +18611,13 @@
                     <a:p>
                       <a:pPr algn="ctr"/>
                       <a:r>
-                        <a:rPr sz="1150" b="0" i="0">
+                        <a:rPr sz="1000" b="0" i="0">
                           <a:solidFill>
                             <a:srgbClr val="1A1A1A"/>
                           </a:solidFill>
                           <a:latin typeface="Arial"/>
                         </a:rPr>
-                        <a:t>re-analysis</a:t>
+                        <a:t>22.7</a:t>
                       </a:r>
                     </a:p>
                   </a:txBody>
@@ -18604,7 +18628,7 @@
                   </a:tcPr>
                 </a:tc>
               </a:tr>
-              <a:tr h="365760">
+              <a:tr h="301752">
                 <a:tc>
                   <a:txBody>
                     <a:bodyPr wrap="square"/>
@@ -18612,7 +18636,7 @@
                     <a:p>
                       <a:pPr algn="l"/>
                       <a:r>
-                        <a:rPr sz="1150" b="1" i="0">
+                        <a:rPr sz="1000" b="1" i="0">
                           <a:solidFill>
                             <a:srgbClr val="1A1A1A"/>
                           </a:solidFill>
@@ -18635,13 +18659,13 @@
                     <a:p>
                       <a:pPr algn="ctr"/>
                       <a:r>
-                        <a:rPr sz="1150" b="0" i="0">
+                        <a:rPr sz="1000" b="0" i="0">
                           <a:solidFill>
                             <a:srgbClr val="1A1A1A"/>
                           </a:solidFill>
                           <a:latin typeface="Arial"/>
                         </a:rPr>
-                        <a:t>17.01 mA</a:t>
+                        <a:t>18.75</a:t>
                       </a:r>
                     </a:p>
                   </a:txBody>
@@ -18658,13 +18682,13 @@
                     <a:p>
                       <a:pPr algn="ctr"/>
                       <a:r>
-                        <a:rPr sz="1150" b="0" i="0">
+                        <a:rPr sz="1000" b="0" i="0">
                           <a:solidFill>
                             <a:srgbClr val="1A1A1A"/>
                           </a:solidFill>
                           <a:latin typeface="Arial"/>
                         </a:rPr>
-                        <a:t>16.7 dB</a:t>
+                        <a:t>18.71</a:t>
                       </a:r>
                     </a:p>
                   </a:txBody>
@@ -18681,13 +18705,13 @@
                     <a:p>
                       <a:pPr algn="ctr"/>
                       <a:r>
-                        <a:rPr sz="1150" b="0" i="0">
+                        <a:rPr sz="1000" b="0" i="0">
                           <a:solidFill>
                             <a:srgbClr val="1A1A1A"/>
                           </a:solidFill>
                           <a:latin typeface="Arial"/>
                         </a:rPr>
-                        <a:t>re-analysis</a:t>
+                        <a:t>21.3</a:t>
                       </a:r>
                     </a:p>
                   </a:txBody>
@@ -18704,13 +18728,13 @@
                     <a:p>
                       <a:pPr algn="ctr"/>
                       <a:r>
-                        <a:rPr sz="1150" b="0" i="0">
+                        <a:rPr sz="1000" b="0" i="0">
                           <a:solidFill>
                             <a:srgbClr val="1A1A1A"/>
                           </a:solidFill>
                           <a:latin typeface="Arial"/>
                         </a:rPr>
-                        <a:t>re-analysis</a:t>
+                        <a:t>21.7</a:t>
                       </a:r>
                     </a:p>
                   </a:txBody>
@@ -18727,55 +18751,196 @@
       </p:graphicFrame>
       <p:sp>
         <p:nvSpPr>
-          <p:cNvPr id="7" name="Rounded Rectangle 6"/>
-          <p:cNvSpPr/>
-          <p:nvPr/>
-        </p:nvSpPr>
-        <p:spPr>
-          <a:xfrm>
-            <a:off x="8503920" y="4434840"/>
-            <a:ext cx="3246120" cy="1371600"/>
-          </a:xfrm>
-          <a:prstGeom prst="roundRect">
-            <a:avLst>
-              <a:gd name="adj" fmla="val 50000"/>
-            </a:avLst>
-          </a:prstGeom>
-          <a:solidFill>
-            <a:srgbClr val="FDEBEC"/>
-          </a:solidFill>
-          <a:ln>
-            <a:noFill/>
-          </a:ln>
-          <a:effectLst/>
-        </p:spPr>
-        <p:style>
-          <a:lnRef idx="1">
-            <a:schemeClr val="accent1"/>
-          </a:lnRef>
-          <a:fillRef idx="3">
-            <a:schemeClr val="accent1"/>
-          </a:fillRef>
-          <a:effectRef idx="2">
-            <a:schemeClr val="accent1"/>
-          </a:effectRef>
-          <a:fontRef idx="minor">
-            <a:schemeClr val="lt1"/>
-          </a:fontRef>
-        </p:style>
-        <p:txBody>
-          <a:bodyPr rtlCol="0" anchor="ctr" lIns="27432" rIns="27432" tIns="9144" bIns="9144" wrap="square"/>
-          <a:lstStyle/>
-          <a:p>
-            <a:pPr algn="ctr"/>
-            <a:r>
-              <a:rPr sz="1100" b="1" i="0">
+          <p:cNvPr id="8" name="TextBox 7"/>
+          <p:cNvSpPr txBox="1"/>
+          <p:nvPr/>
+        </p:nvSpPr>
+        <p:spPr>
+          <a:xfrm>
+            <a:off x="6812280" y="6446520"/>
+            <a:ext cx="2743200" cy="274320"/>
+          </a:xfrm>
+          <a:prstGeom prst="rect">
+            <a:avLst/>
+          </a:prstGeom>
+          <a:noFill/>
+        </p:spPr>
+        <p:txBody>
+          <a:bodyPr wrap="square" lIns="27432" rIns="27432" tIns="18288" bIns="18288" anchor="t">
+            <a:spAutoFit/>
+          </a:bodyPr>
+          <a:lstStyle/>
+          <a:p>
+            <a:pPr algn="l">
+              <a:spcAft>
+                <a:spcPts val="400"/>
+              </a:spcAft>
+            </a:pPr>
+            <a:r>
+              <a:rPr sz="900" b="0" i="1">
                 <a:solidFill>
-                  <a:srgbClr val="F20013"/>
+                  <a:srgbClr val="5A606E"/>
                 </a:solidFill>
                 <a:latin typeface="Arial"/>
               </a:rPr>
-              <a:t>INTERCONNECT eyes: the first run folded the start-up interval; fixed, re-analysis pending</a:t>
+              <a:t>height in mA · ER in dB</a:t>
+            </a:r>
+          </a:p>
+        </p:txBody>
+      </p:sp>
+      <p:sp>
+        <p:nvSpPr>
+          <p:cNvPr id="9" name="TextBox 8"/>
+          <p:cNvSpPr txBox="1"/>
+          <p:nvPr/>
+        </p:nvSpPr>
+        <p:spPr>
+          <a:xfrm>
+            <a:off x="9738360" y="4572000"/>
+            <a:ext cx="2194560" cy="731520"/>
+          </a:xfrm>
+          <a:prstGeom prst="rect">
+            <a:avLst/>
+          </a:prstGeom>
+          <a:noFill/>
+        </p:spPr>
+        <p:txBody>
+          <a:bodyPr wrap="square" lIns="27432" rIns="27432" tIns="18288" bIns="18288" anchor="t">
+            <a:spAutoFit/>
+          </a:bodyPr>
+          <a:lstStyle/>
+          <a:p>
+            <a:pPr algn="l">
+              <a:spcAft>
+                <a:spcPts val="0"/>
+              </a:spcAft>
+            </a:pPr>
+            <a:r>
+              <a:rPr sz="4000" b="1" i="0">
+                <a:solidFill>
+                  <a:srgbClr val="0E2268"/>
+                </a:solidFill>
+                <a:latin typeface="Arial"/>
+              </a:rPr>
+              <a:t>≤ 0.4 %</a:t>
+            </a:r>
+          </a:p>
+        </p:txBody>
+      </p:sp>
+      <p:sp>
+        <p:nvSpPr>
+          <p:cNvPr id="10" name="TextBox 9"/>
+          <p:cNvSpPr txBox="1"/>
+          <p:nvPr/>
+        </p:nvSpPr>
+        <p:spPr>
+          <a:xfrm>
+            <a:off x="9738360" y="5285232"/>
+            <a:ext cx="2194560" cy="457200"/>
+          </a:xfrm>
+          <a:prstGeom prst="rect">
+            <a:avLst/>
+          </a:prstGeom>
+          <a:noFill/>
+        </p:spPr>
+        <p:txBody>
+          <a:bodyPr wrap="square" lIns="27432" rIns="27432" tIns="18288" bIns="18288" anchor="t">
+            <a:spAutoFit/>
+          </a:bodyPr>
+          <a:lstStyle/>
+          <a:p>
+            <a:pPr algn="l">
+              <a:spcAft>
+                <a:spcPts val="0"/>
+              </a:spcAft>
+            </a:pPr>
+            <a:r>
+              <a:rPr sz="1100" b="0" i="0">
+                <a:solidFill>
+                  <a:srgbClr val="5A606E"/>
+                </a:solidFill>
+                <a:latin typeface="Arial"/>
+              </a:rPr>
+              <a:t>eye height,
+every N</a:t>
+            </a:r>
+          </a:p>
+        </p:txBody>
+      </p:sp>
+      <p:sp>
+        <p:nvSpPr>
+          <p:cNvPr id="11" name="TextBox 10"/>
+          <p:cNvSpPr txBox="1"/>
+          <p:nvPr/>
+        </p:nvSpPr>
+        <p:spPr>
+          <a:xfrm>
+            <a:off x="9738360" y="5669280"/>
+            <a:ext cx="2194560" cy="731520"/>
+          </a:xfrm>
+          <a:prstGeom prst="rect">
+            <a:avLst/>
+          </a:prstGeom>
+          <a:noFill/>
+        </p:spPr>
+        <p:txBody>
+          <a:bodyPr wrap="square" lIns="27432" rIns="27432" tIns="18288" bIns="18288" anchor="t">
+            <a:spAutoFit/>
+          </a:bodyPr>
+          <a:lstStyle/>
+          <a:p>
+            <a:pPr algn="l">
+              <a:spcAft>
+                <a:spcPts val="0"/>
+              </a:spcAft>
+            </a:pPr>
+            <a:r>
+              <a:rPr sz="4000" b="1" i="0">
+                <a:solidFill>
+                  <a:srgbClr val="1C8C82"/>
+                </a:solidFill>
+                <a:latin typeface="Arial"/>
+              </a:rPr>
+              <a:t>≤ 0.2 %</a:t>
+            </a:r>
+          </a:p>
+        </p:txBody>
+      </p:sp>
+      <p:sp>
+        <p:nvSpPr>
+          <p:cNvPr id="12" name="TextBox 11"/>
+          <p:cNvSpPr txBox="1"/>
+          <p:nvPr/>
+        </p:nvSpPr>
+        <p:spPr>
+          <a:xfrm>
+            <a:off x="9738360" y="6382512"/>
+            <a:ext cx="2194560" cy="457200"/>
+          </a:xfrm>
+          <a:prstGeom prst="rect">
+            <a:avLst/>
+          </a:prstGeom>
+          <a:noFill/>
+        </p:spPr>
+        <p:txBody>
+          <a:bodyPr wrap="square" lIns="27432" rIns="27432" tIns="18288" bIns="18288" anchor="t">
+            <a:spAutoFit/>
+          </a:bodyPr>
+          <a:lstStyle/>
+          <a:p>
+            <a:pPr algn="l">
+              <a:spcAft>
+                <a:spcPts val="0"/>
+              </a:spcAft>
+            </a:pPr>
+            <a:r>
+              <a:rPr sz="1100" b="0" i="0">
+                <a:solidFill>
+                  <a:srgbClr val="5A606E"/>
+                </a:solidFill>
+                <a:latin typeface="Arial"/>
+              </a:rPr>
+              <a:t>OMA, every N</a:t>
             </a:r>
           </a:p>
         </p:txBody>
@@ -26158,7 +26323,7 @@
                 </a:solidFill>
                 <a:latin typeface="Arial"/>
               </a:rPr>
-              <a:t>fixed in the eye check; saved traces can be re-analysed without re-running INTERCONNECT</a:t>
+              <a:t>fixed; the saved traces re-folded from the arrival: eye height within 0.4 % of Python (slide 19)</a:t>
             </a:r>
           </a:p>
         </p:txBody>

</xml_diff>